<commit_message>
ASR revision: density-unit correction, exposure classification, converged Sobol, matched-exposure and energy audits, regenerated manuscript
Co-Authored-By: Tatsuki Onishi <bougtoir@gmail.com>
</commit_message>
<xml_diff>
--- a/manuscript/manuscript_figures.pptx
+++ b/manuscript/manuscript_figures.pptx
@@ -17,6 +17,9 @@
     <p:sldId id="265" r:id="rId16"/>
     <p:sldId id="266" r:id="rId17"/>
     <p:sldId id="267" r:id="rId18"/>
+    <p:sldId id="268" r:id="rId19"/>
+    <p:sldId id="269" r:id="rId20"/>
+    <p:sldId id="270" r:id="rId21"/>
   </p:sldIdLst>
   <p:sldSz cx="12191695" cy="6858000" type="screen4x3"/>
   <p:notesSz cx="6858000" cy="9144000"/>
@@ -3217,14 +3220,14 @@
           <a:p>
             <a:r>
               <a:rPr sz="2400" b="1"/>
-              <a:t>Figure S2</a:t>
+              <a:t>Figure 8</a:t>
             </a:r>
           </a:p>
         </p:txBody>
       </p:sp>
       <p:pic>
         <p:nvPicPr>
-          <p:cNvPr id="3" name="Picture 2" descr="figS2_mc_hist.png"/>
+          <p:cNvPr id="3" name="Picture 2" descr="fig8_energy_bounds.png"/>
           <p:cNvPicPr>
             <a:picLocks noChangeAspect="1"/>
           </p:cNvPicPr>
@@ -3239,7 +3242,7 @@
         <p:spPr>
           <a:xfrm>
             <a:off x="2743200" y="1051560"/>
-            <a:ext cx="5715000" cy="4572000"/>
+            <a:ext cx="6286500" cy="4572000"/>
           </a:xfrm>
           <a:prstGeom prst="rect">
             <a:avLst/>
@@ -3270,7 +3273,7 @@
           <a:p>
             <a:r>
               <a:rPr sz="1200"/>
-              <a:t>Figure S2. Monte Carlo distribution of target extra delta-v.</a:t>
+              <a:t>Figure 8. Sustained power corresponding to the thermodynamic lower bounds of Table 8, versus altitude and enhancement amplitude.</a:t>
             </a:r>
           </a:p>
         </p:txBody>
@@ -3317,14 +3320,14 @@
           <a:p>
             <a:r>
               <a:rPr sz="2400" b="1"/>
-              <a:t>Figure S3</a:t>
+              <a:t>Figure S1</a:t>
             </a:r>
           </a:p>
         </p:txBody>
       </p:sp>
       <p:pic>
         <p:nvPicPr>
-          <p:cNvPr id="3" name="Picture 2" descr="figS3_sobol.png"/>
+          <p:cNvPr id="3" name="Picture 2" descr="figS1_negative_controls.png"/>
           <p:cNvPicPr>
             <a:picLocks noChangeAspect="1"/>
           </p:cNvPicPr>
@@ -3339,7 +3342,7 @@
         <p:spPr>
           <a:xfrm>
             <a:off x="2743200" y="1051560"/>
-            <a:ext cx="6858000" cy="4572000"/>
+            <a:ext cx="8001000" cy="4572000"/>
           </a:xfrm>
           <a:prstGeom prst="rect">
             <a:avLst/>
@@ -3370,7 +3373,7 @@
           <a:p>
             <a:r>
               <a:rPr sz="1200"/>
-              <a:t>Figure S3. Sobol' first-order and total-order indices.</a:t>
+              <a:t>Figure S1. Extra delta-v for each mandatory negative control.</a:t>
             </a:r>
           </a:p>
         </p:txBody>
@@ -3401,6 +3404,306 @@
         </p:nvSpPr>
         <p:spPr>
           <a:xfrm>
+            <a:off x="548640" y="228600"/>
+            <a:ext cx="11064240" cy="731520"/>
+          </a:xfrm>
+          <a:prstGeom prst="rect">
+            <a:avLst/>
+          </a:prstGeom>
+          <a:noFill/>
+        </p:spPr>
+        <p:txBody>
+          <a:bodyPr wrap="none">
+            <a:spAutoFit/>
+          </a:bodyPr>
+          <a:lstStyle/>
+          <a:p>
+            <a:r>
+              <a:rPr sz="2400" b="1"/>
+              <a:t>Figure S2</a:t>
+            </a:r>
+          </a:p>
+        </p:txBody>
+      </p:sp>
+      <p:pic>
+        <p:nvPicPr>
+          <p:cNvPr id="3" name="Picture 2" descr="figS2_mc_hist.png"/>
+          <p:cNvPicPr>
+            <a:picLocks noChangeAspect="1"/>
+          </p:cNvPicPr>
+          <p:nvPr/>
+        </p:nvPicPr>
+        <p:blipFill>
+          <a:blip r:embed="rId2"/>
+          <a:stretch>
+            <a:fillRect/>
+          </a:stretch>
+        </p:blipFill>
+        <p:spPr>
+          <a:xfrm>
+            <a:off x="2743200" y="1051560"/>
+            <a:ext cx="5715000" cy="4572000"/>
+          </a:xfrm>
+          <a:prstGeom prst="rect">
+            <a:avLst/>
+          </a:prstGeom>
+        </p:spPr>
+      </p:pic>
+      <p:sp>
+        <p:nvSpPr>
+          <p:cNvPr id="4" name="TextBox 3"/>
+          <p:cNvSpPr txBox="1"/>
+          <p:nvPr/>
+        </p:nvSpPr>
+        <p:spPr>
+          <a:xfrm>
+            <a:off x="548640" y="5806440"/>
+            <a:ext cx="11064240" cy="822960"/>
+          </a:xfrm>
+          <a:prstGeom prst="rect">
+            <a:avLst/>
+          </a:prstGeom>
+          <a:noFill/>
+        </p:spPr>
+        <p:txBody>
+          <a:bodyPr wrap="square">
+            <a:spAutoFit/>
+          </a:bodyPr>
+          <a:lstStyle/>
+          <a:p>
+            <a:r>
+              <a:rPr sz="1200"/>
+              <a:t>Figure S2. Monte Carlo distribution of target extra delta-v.</a:t>
+            </a:r>
+          </a:p>
+        </p:txBody>
+      </p:sp>
+    </p:spTree>
+  </p:cSld>
+  <p:clrMapOvr>
+    <a:masterClrMapping/>
+  </p:clrMapOvr>
+</p:sld>
+</file>
+
+<file path=ppt/slides/slide13.xml><?xml version="1.0" encoding="utf-8"?>
+<p:sld xmlns:a="http://schemas.openxmlformats.org/drawingml/2006/main" xmlns:p="http://schemas.openxmlformats.org/presentationml/2006/main" xmlns:r="http://schemas.openxmlformats.org/officeDocument/2006/relationships">
+  <p:cSld>
+    <p:spTree>
+      <p:nvGrpSpPr>
+        <p:cNvPr id="1" name=""/>
+        <p:cNvGrpSpPr/>
+        <p:nvPr/>
+      </p:nvGrpSpPr>
+      <p:grpSpPr/>
+      <p:sp>
+        <p:nvSpPr>
+          <p:cNvPr id="2" name="TextBox 1"/>
+          <p:cNvSpPr txBox="1"/>
+          <p:nvPr/>
+        </p:nvSpPr>
+        <p:spPr>
+          <a:xfrm>
+            <a:off x="548640" y="228600"/>
+            <a:ext cx="11064240" cy="731520"/>
+          </a:xfrm>
+          <a:prstGeom prst="rect">
+            <a:avLst/>
+          </a:prstGeom>
+          <a:noFill/>
+        </p:spPr>
+        <p:txBody>
+          <a:bodyPr wrap="none">
+            <a:spAutoFit/>
+          </a:bodyPr>
+          <a:lstStyle/>
+          <a:p>
+            <a:r>
+              <a:rPr sz="2400" b="1"/>
+              <a:t>Figure S3</a:t>
+            </a:r>
+          </a:p>
+        </p:txBody>
+      </p:sp>
+      <p:pic>
+        <p:nvPicPr>
+          <p:cNvPr id="3" name="Picture 2" descr="figS3_sobol.png"/>
+          <p:cNvPicPr>
+            <a:picLocks noChangeAspect="1"/>
+          </p:cNvPicPr>
+          <p:nvPr/>
+        </p:nvPicPr>
+        <p:blipFill>
+          <a:blip r:embed="rId2"/>
+          <a:stretch>
+            <a:fillRect/>
+          </a:stretch>
+        </p:blipFill>
+        <p:spPr>
+          <a:xfrm>
+            <a:off x="2743200" y="1051560"/>
+            <a:ext cx="6858000" cy="4572000"/>
+          </a:xfrm>
+          <a:prstGeom prst="rect">
+            <a:avLst/>
+          </a:prstGeom>
+        </p:spPr>
+      </p:pic>
+      <p:sp>
+        <p:nvSpPr>
+          <p:cNvPr id="4" name="TextBox 3"/>
+          <p:cNvSpPr txBox="1"/>
+          <p:nvPr/>
+        </p:nvSpPr>
+        <p:spPr>
+          <a:xfrm>
+            <a:off x="548640" y="5806440"/>
+            <a:ext cx="11064240" cy="822960"/>
+          </a:xfrm>
+          <a:prstGeom prst="rect">
+            <a:avLst/>
+          </a:prstGeom>
+          <a:noFill/>
+        </p:spPr>
+        <p:txBody>
+          <a:bodyPr wrap="square">
+            <a:spAutoFit/>
+          </a:bodyPr>
+          <a:lstStyle/>
+          <a:p>
+            <a:r>
+              <a:rPr sz="1200"/>
+              <a:t>Figure S3. Sobol' first-order and total-order indices.</a:t>
+            </a:r>
+          </a:p>
+        </p:txBody>
+      </p:sp>
+    </p:spTree>
+  </p:cSld>
+  <p:clrMapOvr>
+    <a:masterClrMapping/>
+  </p:clrMapOvr>
+</p:sld>
+</file>
+
+<file path=ppt/slides/slide14.xml><?xml version="1.0" encoding="utf-8"?>
+<p:sld xmlns:a="http://schemas.openxmlformats.org/drawingml/2006/main" xmlns:p="http://schemas.openxmlformats.org/presentationml/2006/main" xmlns:r="http://schemas.openxmlformats.org/officeDocument/2006/relationships">
+  <p:cSld>
+    <p:spTree>
+      <p:nvGrpSpPr>
+        <p:cNvPr id="1" name=""/>
+        <p:cNvGrpSpPr/>
+        <p:nvPr/>
+      </p:nvGrpSpPr>
+      <p:grpSpPr/>
+      <p:sp>
+        <p:nvSpPr>
+          <p:cNvPr id="2" name="TextBox 1"/>
+          <p:cNvSpPr txBox="1"/>
+          <p:nvPr/>
+        </p:nvSpPr>
+        <p:spPr>
+          <a:xfrm>
+            <a:off x="548640" y="228600"/>
+            <a:ext cx="11064240" cy="731520"/>
+          </a:xfrm>
+          <a:prstGeom prst="rect">
+            <a:avLst/>
+          </a:prstGeom>
+          <a:noFill/>
+        </p:spPr>
+        <p:txBody>
+          <a:bodyPr wrap="none">
+            <a:spAutoFit/>
+          </a:bodyPr>
+          <a:lstStyle/>
+          <a:p>
+            <a:r>
+              <a:rPr sz="2400" b="1"/>
+              <a:t>Figure S4</a:t>
+            </a:r>
+          </a:p>
+        </p:txBody>
+      </p:sp>
+      <p:pic>
+        <p:nvPicPr>
+          <p:cNvPr id="3" name="Picture 2" descr="figS4_transport_grid_sensitivity.png"/>
+          <p:cNvPicPr>
+            <a:picLocks noChangeAspect="1"/>
+          </p:cNvPicPr>
+          <p:nvPr/>
+        </p:nvPicPr>
+        <p:blipFill>
+          <a:blip r:embed="rId2"/>
+          <a:stretch>
+            <a:fillRect/>
+          </a:stretch>
+        </p:blipFill>
+        <p:spPr>
+          <a:xfrm>
+            <a:off x="2743200" y="1051560"/>
+            <a:ext cx="6858000" cy="4572000"/>
+          </a:xfrm>
+          <a:prstGeom prst="rect">
+            <a:avLst/>
+          </a:prstGeom>
+        </p:spPr>
+      </p:pic>
+      <p:sp>
+        <p:nvSpPr>
+          <p:cNvPr id="4" name="TextBox 3"/>
+          <p:cNvSpPr txBox="1"/>
+          <p:nvPr/>
+        </p:nvSpPr>
+        <p:spPr>
+          <a:xfrm>
+            <a:off x="548640" y="5806440"/>
+            <a:ext cx="11064240" cy="822960"/>
+          </a:xfrm>
+          <a:prstGeom prst="rect">
+            <a:avLst/>
+          </a:prstGeom>
+          <a:noFill/>
+        </p:spPr>
+        <p:txBody>
+          <a:bodyPr wrap="square">
+            <a:spAutoFit/>
+          </a:bodyPr>
+          <a:lstStyle/>
+          <a:p>
+            <a:r>
+              <a:rPr sz="1200"/>
+              <a:t>Figure S4. Transport-grid sensitivity of the surviving fraction.</a:t>
+            </a:r>
+          </a:p>
+        </p:txBody>
+      </p:sp>
+    </p:spTree>
+  </p:cSld>
+  <p:clrMapOvr>
+    <a:masterClrMapping/>
+  </p:clrMapOvr>
+</p:sld>
+</file>
+
+<file path=ppt/slides/slide15.xml><?xml version="1.0" encoding="utf-8"?>
+<p:sld xmlns:a="http://schemas.openxmlformats.org/drawingml/2006/main" xmlns:p="http://schemas.openxmlformats.org/presentationml/2006/main" xmlns:r="http://schemas.openxmlformats.org/officeDocument/2006/relationships">
+  <p:cSld>
+    <p:spTree>
+      <p:nvGrpSpPr>
+        <p:cNvPr id="1" name=""/>
+        <p:cNvGrpSpPr/>
+        <p:nvPr/>
+      </p:nvGrpSpPr>
+      <p:grpSpPr/>
+      <p:sp>
+        <p:nvSpPr>
+          <p:cNvPr id="2" name="TextBox 1"/>
+          <p:cNvSpPr txBox="1"/>
+          <p:nvPr/>
+        </p:nvSpPr>
+        <p:spPr>
+          <a:xfrm>
             <a:off x="548640" y="365760"/>
             <a:ext cx="11064240" cy="914400"/>
           </a:xfrm>
@@ -3540,31 +3843,37 @@
           <a:p>
             <a:r>
               <a:rPr sz="1600"/>
-              <a:t>• Earth-fixed pulse adds only ~4.32e-6 m/s per event to the case-A target (single tens-of-seconds transit)</a:t>
+              <a:t>• Earth-fixed pulse: 3.98e-3 m/s per event (4.4% duty cycle) = 3.5% of natural drag over the same window</a:t>
             </a:r>
           </a:p>
           <a:p>
             <a:r>
               <a:rPr sz="1600"/>
-              <a:t>• Idealized on-target tracking bound: 7.45e-3 m/s per day</a:t>
+              <a:t>• Idealized co-location bound: 6.87 m/s/day = delta x natural drag — an upper bound, not a mechanism</a:t>
             </a:r>
           </a:p>
           <a:p>
             <a:r>
               <a:rPr sz="1600"/>
-              <a:t>• Localization changes collateral, not benefit: selectivity 16.0 (uniform) vs 1.49e6 (localized) for the same target benefit</a:t>
+              <a:t>• Gap decomposition: duration 12x x occupancy 22.5x x in-patch amplitude 6.3x closes to 1.5%</a:t>
             </a:r>
           </a:p>
           <a:p>
             <a:r>
               <a:rPr sz="1600"/>
-              <a:t>• Scaling collapse: Pi = dv B/(rho delta v^2 T) = 1.02 ± 0.02 (R^2 = 0.9999)</a:t>
+              <a:t>• Localization buys collateral suppression, not benefit; the comparison depends on the matching convention</a:t>
             </a:r>
           </a:p>
           <a:p>
             <a:r>
               <a:rPr sz="1600"/>
-              <a:t>• Transport limit: only 41% of (kappa, u) combinations let a patch survive one hour</a:t>
+              <a:t>• Transport: 11/27 surveyed design combinations survive 1 h; none when selective patches meet 100 m/s winds</a:t>
+            </a:r>
+          </a:p>
+          <a:p>
+            <a:r>
+              <a:rPr sz="1600"/>
+              <a:t>• Energetics: ~3.56e7 W sustained (thermodynamic lower bound) for delta=5 over a 200 km patch at 400 km</a:t>
             </a:r>
           </a:p>
           <a:p>
@@ -3770,7 +4079,7 @@
           <a:p>
             <a:r>
               <a:rPr sz="1200"/>
-              <a:t>Figure 2. Baseline decay lifetime (log10 days) over altitude and ballistic coefficient B in the moderate regime.</a:t>
+              <a:t>Figure 2. Baseline decay lifetime (log10 days) over altitude and ballistic coefficient B in the moderate regime; cells at the horizon are right-censored.</a:t>
             </a:r>
           </a:p>
         </p:txBody>
@@ -3917,14 +4226,14 @@
           <a:p>
             <a:r>
               <a:rPr sz="2400" b="1"/>
-              <a:t>Figure 4</a:t>
+              <a:t>Figure 7</a:t>
             </a:r>
           </a:p>
         </p:txBody>
       </p:sp>
       <p:pic>
         <p:nvPicPr>
-          <p:cNvPr id="3" name="Picture 2" descr="fig4_timing.png"/>
+          <p:cNvPr id="3" name="Picture 2" descr="fig7_matched_exposure.png"/>
           <p:cNvPicPr>
             <a:picLocks noChangeAspect="1"/>
           </p:cNvPicPr>
@@ -3939,7 +4248,7 @@
         <p:spPr>
           <a:xfrm>
             <a:off x="2743200" y="1051560"/>
-            <a:ext cx="6858000" cy="4572000"/>
+            <a:ext cx="10287000" cy="4572000"/>
           </a:xfrm>
           <a:prstGeom prst="rect">
             <a:avLst/>
@@ -3970,7 +4279,7 @@
           <a:p>
             <a:r>
               <a:rPr sz="1200"/>
-              <a:t>Figure 4. Target extra delta-v versus intervention reference time for a best-case-sited fixed pulse and for a 4 h tracking window.</a:t>
+              <a:t>Figure 7. Target benefit (left) and protected-object collateral (right) under four matching conventions: the idealized localized bound, matched target exposure, matched enhanced spacetime volume, and matched lower-bound thermal energy.</a:t>
             </a:r>
           </a:p>
         </p:txBody>
@@ -4017,14 +4326,14 @@
           <a:p>
             <a:r>
               <a:rPr sz="2400" b="1"/>
-              <a:t>Figure 5</a:t>
+              <a:t>Figure 6</a:t>
             </a:r>
           </a:p>
         </p:txBody>
       </p:sp>
       <p:pic>
         <p:nvPicPr>
-          <p:cNvPr id="3" name="Picture 2" descr="fig5_pareto.png"/>
+          <p:cNvPr id="3" name="Picture 2" descr="fig6_scaling_collapse.png"/>
           <p:cNvPicPr>
             <a:picLocks noChangeAspect="1"/>
           </p:cNvPicPr>
@@ -4039,7 +4348,7 @@
         <p:spPr>
           <a:xfrm>
             <a:off x="2743200" y="1051560"/>
-            <a:ext cx="6286500" cy="4572000"/>
+            <a:ext cx="5715000" cy="4572000"/>
           </a:xfrm>
           <a:prstGeom prst="rect">
             <a:avLst/>
@@ -4070,7 +4379,7 @@
           <a:p>
             <a:r>
               <a:rPr sz="1200"/>
-              <a:t>Figure 5. Target benefit against protected-object collateral over the design sweep; the Pareto front is highlighted and colour encodes horizontal patch scale.</a:t>
+              <a:t>Figure 6. Simulated extra delta-v against the predicted value rho*delta*v_rel^2*T/(2B); all regimes, altitudes and ballistic coefficients collapse onto the identity line.</a:t>
             </a:r>
           </a:p>
         </p:txBody>
@@ -4117,14 +4426,14 @@
           <a:p>
             <a:r>
               <a:rPr sz="2400" b="1"/>
-              <a:t>Figure 6</a:t>
+              <a:t>Figure 4</a:t>
             </a:r>
           </a:p>
         </p:txBody>
       </p:sp>
       <p:pic>
         <p:nvPicPr>
-          <p:cNvPr id="3" name="Picture 2" descr="fig6_scaling_collapse.png"/>
+          <p:cNvPr id="3" name="Picture 2" descr="fig4_timing.png"/>
           <p:cNvPicPr>
             <a:picLocks noChangeAspect="1"/>
           </p:cNvPicPr>
@@ -4139,7 +4448,7 @@
         <p:spPr>
           <a:xfrm>
             <a:off x="2743200" y="1051560"/>
-            <a:ext cx="5715000" cy="4572000"/>
+            <a:ext cx="6858000" cy="4572000"/>
           </a:xfrm>
           <a:prstGeom prst="rect">
             <a:avLst/>
@@ -4170,7 +4479,7 @@
           <a:p>
             <a:r>
               <a:rPr sz="1200"/>
-              <a:t>Figure 6. Simulated extra delta-v against the predicted value rho*delta*v^2*T/(2B); all regimes, altitudes and ballistic coefficients collapse onto the identity line.</a:t>
+              <a:t>Figure 4. Target extra delta-v versus intervention reference time for a best-case-sited fixed pulse and for a 4 h tracking window.</a:t>
             </a:r>
           </a:p>
         </p:txBody>
@@ -4217,14 +4526,14 @@
           <a:p>
             <a:r>
               <a:rPr sz="2400" b="1"/>
-              <a:t>Figure S1</a:t>
+              <a:t>Figure 5</a:t>
             </a:r>
           </a:p>
         </p:txBody>
       </p:sp>
       <p:pic>
         <p:nvPicPr>
-          <p:cNvPr id="3" name="Picture 2" descr="figS1_negative_controls.png"/>
+          <p:cNvPr id="3" name="Picture 2" descr="fig5_pareto.png"/>
           <p:cNvPicPr>
             <a:picLocks noChangeAspect="1"/>
           </p:cNvPicPr>
@@ -4239,7 +4548,7 @@
         <p:spPr>
           <a:xfrm>
             <a:off x="2743200" y="1051560"/>
-            <a:ext cx="8001000" cy="4572000"/>
+            <a:ext cx="6286500" cy="4572000"/>
           </a:xfrm>
           <a:prstGeom prst="rect">
             <a:avLst/>
@@ -4270,7 +4579,7 @@
           <a:p>
             <a:r>
               <a:rPr sz="1200"/>
-              <a:t>Figure S1. Extra delta-v for each mandatory negative control.</a:t>
+              <a:t>Figure 5. Target benefit against protected-object collateral over the design sweep; the Pareto front is highlighted and colour encodes horizontal patch scale.</a:t>
             </a:r>
           </a:p>
         </p:txBody>

</xml_diff>

<commit_message>
Hostile-review + hardcode-audit revision: inject all numbers, renumber display items, add provenance tests
Co-Authored-By: Tatsuki Onishi <bougtoir@gmail.com>
</commit_message>
<xml_diff>
--- a/manuscript/manuscript_figures.pptx
+++ b/manuscript/manuscript_figures.pptx
@@ -3155,7 +3155,7 @@
           <a:p>
             <a:r>
               <a:rPr sz="1600"/>
-              <a:t>• T. Onishi et al. — boundary study, synthetic targets only</a:t>
+              <a:t>• T. Onishi — boundary study, synthetic targets only</a:t>
             </a:r>
           </a:p>
           <a:p>
@@ -3327,7 +3327,7 @@
       </p:sp>
       <p:pic>
         <p:nvPicPr>
-          <p:cNvPr id="3" name="Picture 2" descr="figS1_negative_controls.png"/>
+          <p:cNvPr id="3" name="Picture 2" descr="figS4_transport_grid_sensitivity.png"/>
           <p:cNvPicPr>
             <a:picLocks noChangeAspect="1"/>
           </p:cNvPicPr>
@@ -3342,7 +3342,7 @@
         <p:spPr>
           <a:xfrm>
             <a:off x="2743200" y="1051560"/>
-            <a:ext cx="8001000" cy="4572000"/>
+            <a:ext cx="6858000" cy="4572000"/>
           </a:xfrm>
           <a:prstGeom prst="rect">
             <a:avLst/>
@@ -3373,7 +3373,7 @@
           <a:p>
             <a:r>
               <a:rPr sz="1200"/>
-              <a:t>Figure S1. Extra delta-v for each mandatory negative control.</a:t>
+              <a:t>Figure S1. Transport-grid sensitivity of the surviving fraction.</a:t>
             </a:r>
           </a:p>
         </p:txBody>
@@ -3627,7 +3627,7 @@
       </p:sp>
       <p:pic>
         <p:nvPicPr>
-          <p:cNvPr id="3" name="Picture 2" descr="figS4_transport_grid_sensitivity.png"/>
+          <p:cNvPr id="3" name="Picture 2" descr="figS1_negative_controls.png"/>
           <p:cNvPicPr>
             <a:picLocks noChangeAspect="1"/>
           </p:cNvPicPr>
@@ -3642,7 +3642,7 @@
         <p:spPr>
           <a:xfrm>
             <a:off x="2743200" y="1051560"/>
-            <a:ext cx="6858000" cy="4572000"/>
+            <a:ext cx="8001000" cy="4572000"/>
           </a:xfrm>
           <a:prstGeom prst="rect">
             <a:avLst/>
@@ -3673,7 +3673,7 @@
           <a:p>
             <a:r>
               <a:rPr sz="1200"/>
-              <a:t>Figure S4. Transport-grid sensitivity of the surviving fraction.</a:t>
+              <a:t>Figure S4. Extra delta-v for each mandatory negative control.</a:t>
             </a:r>
           </a:p>
         </p:txBody>
@@ -4226,7 +4226,7 @@
           <a:p>
             <a:r>
               <a:rPr sz="2400" b="1"/>
-              <a:t>Figure 7</a:t>
+              <a:t>Figure 4</a:t>
             </a:r>
           </a:p>
         </p:txBody>
@@ -4279,7 +4279,7 @@
           <a:p>
             <a:r>
               <a:rPr sz="1200"/>
-              <a:t>Figure 7. Target benefit (left) and protected-object collateral (right) under four matching conventions: the idealized localized bound, matched target exposure, matched enhanced spacetime volume, and matched lower-bound thermal energy.</a:t>
+              <a:t>Figure 4. Target benefit (left) and protected-object collateral (right) under four matching conventions: the idealized localized bound, matched target exposure, matched enhanced spacetime volume, and matched lower-bound thermal energy.</a:t>
             </a:r>
           </a:p>
         </p:txBody>
@@ -4326,7 +4326,7 @@
           <a:p>
             <a:r>
               <a:rPr sz="2400" b="1"/>
-              <a:t>Figure 6</a:t>
+              <a:t>Figure 5</a:t>
             </a:r>
           </a:p>
         </p:txBody>
@@ -4379,7 +4379,7 @@
           <a:p>
             <a:r>
               <a:rPr sz="1200"/>
-              <a:t>Figure 6. Simulated extra delta-v against the predicted value rho*delta*v_rel^2*T/(2B); all regimes, altitudes and ballistic coefficients collapse onto the identity line.</a:t>
+              <a:t>Figure 5. Simulated extra delta-v against the predicted value rho*delta*v_rel^2*T/(2B); all regimes, altitudes and ballistic coefficients collapse onto the identity line.</a:t>
             </a:r>
           </a:p>
         </p:txBody>
@@ -4426,7 +4426,7 @@
           <a:p>
             <a:r>
               <a:rPr sz="2400" b="1"/>
-              <a:t>Figure 4</a:t>
+              <a:t>Figure 6</a:t>
             </a:r>
           </a:p>
         </p:txBody>
@@ -4479,7 +4479,7 @@
           <a:p>
             <a:r>
               <a:rPr sz="1200"/>
-              <a:t>Figure 4. Target extra delta-v versus intervention reference time for a best-case-sited fixed pulse and for a 4 h tracking window.</a:t>
+              <a:t>Figure 6. Target extra delta-v versus intervention reference time for a best-case-sited fixed pulse and for a 4 h tracking window.</a:t>
             </a:r>
           </a:p>
         </p:txBody>
@@ -4526,7 +4526,7 @@
           <a:p>
             <a:r>
               <a:rPr sz="2400" b="1"/>
-              <a:t>Figure 5</a:t>
+              <a:t>Figure 7</a:t>
             </a:r>
           </a:p>
         </p:txBody>
@@ -4579,7 +4579,7 @@
           <a:p>
             <a:r>
               <a:rPr sz="1200"/>
-              <a:t>Figure 5. Target benefit against protected-object collateral over the design sweep; the Pareto front is highlighted and colour encodes horizontal patch scale.</a:t>
+              <a:t>Figure 7. Target benefit against protected-object collateral over the design sweep; the Pareto front is highlighted and colour encodes horizontal patch scale.</a:t>
             </a:r>
           </a:p>
         </p:txBody>

</xml_diff>